<commit_message>
Seminar v2: outline per the 8-part structure (Literature Review, Problem Statement, Thesis Objectives, Proposed work, Experimental Results, Conclusion, Future work)
Co-Authored-By: Claude Sonnet 5.5 <noreply@anthropic.com>
Claude-Session: https://claude.ai/code/session_01T6gEewJ8YaCdmnsfS34RJd
</commit_message>
<xml_diff>
--- a/results/seminar/Seminar_Ibtihal_v2.pptx
+++ b/results/seminar/Seminar_Ibtihal_v2.pptx
@@ -9913,7 +9913,7 @@
           <a:p>
             <a:r>
               <a:rPr lang="en-US" dirty="0"/>
-              <a:t>Nine parts, following the structure of the seminar: introduction, related work, problems, objectives, the proposed method, the parallel strategy, results, conclusion and references.</a:t>
+              <a:t>Eight parts: introduction, literature review, problem statement, thesis objectives, proposed work, experimental results, conclusion and future work.</a:t>
             </a:r>
             <a:endParaRPr lang="en-US" dirty="0"/>
           </a:p>
@@ -13374,7 +13374,7 @@
                 <a:ea typeface="Calibri" pitchFamily="34" charset="-122"/>
                 <a:cs typeface="Calibri" pitchFamily="34" charset="-120"/>
               </a:rPr>
-              <a:t>4 · RESEARCH OBJECTIVE</a:t>
+              <a:t>4 · THESIS OBJECTIVES</a:t>
             </a:r>
             <a:endParaRPr lang="en-US" sz="1100" dirty="0"/>
           </a:p>
@@ -14143,7 +14143,7 @@
                 <a:ea typeface="Calibri" pitchFamily="34" charset="-122"/>
                 <a:cs typeface="Calibri" pitchFamily="34" charset="-120"/>
               </a:rPr>
-              <a:t>5 · PROPOSED METHOD</a:t>
+              <a:t>5 · PROPOSED WORK</a:t>
             </a:r>
             <a:endParaRPr lang="en-US" sz="1100" dirty="0"/>
           </a:p>
@@ -15309,7 +15309,7 @@
                 <a:ea typeface="Calibri" pitchFamily="34" charset="-122"/>
                 <a:cs typeface="Calibri" pitchFamily="34" charset="-120"/>
               </a:rPr>
-              <a:t>5 · PROPOSED METHOD</a:t>
+              <a:t>5 · PROPOSED WORK</a:t>
             </a:r>
             <a:endParaRPr lang="en-US" sz="1100" dirty="0"/>
           </a:p>
@@ -16176,7 +16176,7 @@
                 <a:ea typeface="Calibri" pitchFamily="34" charset="-122"/>
                 <a:cs typeface="Calibri" pitchFamily="34" charset="-120"/>
               </a:rPr>
-              <a:t>5 · PROPOSED METHOD</a:t>
+              <a:t>5 · PROPOSED WORK</a:t>
             </a:r>
             <a:endParaRPr lang="en-US" sz="1100" dirty="0"/>
           </a:p>
@@ -17439,7 +17439,7 @@
                 <a:ea typeface="Calibri" pitchFamily="34" charset="-122"/>
                 <a:cs typeface="Calibri" pitchFamily="34" charset="-120"/>
               </a:rPr>
-              <a:t>5 · PROPOSED METHOD</a:t>
+              <a:t>5 · PROPOSED WORK</a:t>
             </a:r>
             <a:endParaRPr lang="en-US" sz="1100" dirty="0"/>
           </a:p>
@@ -17818,7 +17818,7 @@
                 <a:ea typeface="Calibri" pitchFamily="34" charset="-122"/>
                 <a:cs typeface="Calibri" pitchFamily="34" charset="-120"/>
               </a:rPr>
-              <a:t>5 · PROPOSED METHOD</a:t>
+              <a:t>5 · PROPOSED WORK</a:t>
             </a:r>
             <a:endParaRPr lang="en-US" sz="1100" dirty="0"/>
           </a:p>
@@ -18263,7 +18263,7 @@
                 <a:ea typeface="Calibri" pitchFamily="34" charset="-122"/>
                 <a:cs typeface="Calibri" pitchFamily="34" charset="-120"/>
               </a:rPr>
-              <a:t>5 · PROPOSED METHOD</a:t>
+              <a:t>5 · PROPOSED WORK</a:t>
             </a:r>
             <a:endParaRPr lang="en-US" sz="1100" dirty="0"/>
           </a:p>
@@ -18941,7 +18941,7 @@
                 <a:ea typeface="Calibri" pitchFamily="34" charset="-122"/>
                 <a:cs typeface="Calibri" pitchFamily="34" charset="-120"/>
               </a:rPr>
-              <a:t>6 · PROPOSED PARALLEL COMPUTING STRATEGIES</a:t>
+              <a:t>5 · PROPOSED WORK</a:t>
             </a:r>
             <a:endParaRPr lang="en-US" sz="1100" dirty="0"/>
           </a:p>
@@ -20206,7 +20206,7 @@
                 <a:ea typeface="Calibri" pitchFamily="34" charset="-122"/>
                 <a:cs typeface="Calibri" pitchFamily="34" charset="-120"/>
               </a:rPr>
-              <a:t>6 · PROPOSED PARALLEL COMPUTING STRATEGIES</a:t>
+              <a:t>5 · PROPOSED WORK</a:t>
             </a:r>
             <a:endParaRPr lang="en-US" sz="1100" dirty="0"/>
           </a:p>
@@ -21214,7 +21214,7 @@
                 <a:ea typeface="Calibri" pitchFamily="34" charset="-122"/>
                 <a:cs typeface="Calibri" pitchFamily="34" charset="-120"/>
               </a:rPr>
-              <a:t>6 · PROPOSED PARALLEL COMPUTING STRATEGIES</a:t>
+              <a:t>5 · PROPOSED WORK</a:t>
             </a:r>
             <a:endParaRPr lang="en-US" sz="1100" dirty="0"/>
           </a:p>
@@ -22197,12 +22197,12 @@
         </p:nvSpPr>
         <p:spPr>
           <a:xfrm>
-            <a:off x="548640" y="1463040"/>
-            <a:ext cx="5394960" cy="804672"/>
+            <a:off x="548640" y="1600200"/>
+            <a:ext cx="5394960" cy="914400"/>
           </a:xfrm>
           <a:prstGeom prst="roundRect">
             <a:avLst>
-              <a:gd name="adj" fmla="val 13636"/>
+              <a:gd name="adj" fmla="val 12000"/>
             </a:avLst>
           </a:prstGeom>
           <a:solidFill>
@@ -22218,24 +22218,24 @@
       </p:sp>
       <p:sp>
         <p:nvSpPr>
-          <p:cNvPr id="6" name="Number circle"/>
+          <p:cNvPr id="6" name="Gold diamond"/>
           <p:cNvSpPr/>
           <p:nvPr/>
         </p:nvSpPr>
         <p:spPr>
           <a:xfrm>
-            <a:off x="731520" y="1591056"/>
-            <a:ext cx="548640" cy="548640"/>
-          </a:xfrm>
-          <a:prstGeom prst="ellipse">
+            <a:off x="777240" y="1856232"/>
+            <a:ext cx="402336" cy="402336"/>
+          </a:xfrm>
+          <a:prstGeom prst="diamond">
             <a:avLst/>
           </a:prstGeom>
           <a:solidFill>
-            <a:srgbClr val="6B4FA3"/>
+            <a:srgbClr val="F2B134"/>
           </a:solidFill>
           <a:ln w="12700">
             <a:solidFill>
-              <a:srgbClr val="FFFFFF"/>
+              <a:srgbClr val="F2B134"/>
             </a:solidFill>
             <a:prstDash val="solid"/>
           </a:ln>
@@ -22249,8 +22249,8 @@
         </p:nvSpPr>
         <p:spPr>
           <a:xfrm>
-            <a:off x="731520" y="1591056"/>
-            <a:ext cx="548640" cy="548640"/>
+            <a:off x="1261872" y="1691640"/>
+            <a:ext cx="457200" cy="731520"/>
           </a:xfrm>
           <a:prstGeom prst="rect">
             <a:avLst/>
@@ -22262,13 +22262,13 @@
           <a:bodyPr wrap="square" lIns="0" tIns="0" rIns="0" bIns="0" rtlCol="0" anchor="ctr"/>
           <a:lstStyle/>
           <a:p>
-            <a:pPr algn="ctr" indent="0" marL="0">
+            <a:pPr indent="0" marL="0">
               <a:buNone/>
             </a:pPr>
             <a:r>
-              <a:rPr lang="en-US" sz="2000" b="1" dirty="0">
-                <a:solidFill>
-                  <a:srgbClr val="FFFFFF"/>
+              <a:rPr lang="en-US" sz="2200" b="1" dirty="0">
+                <a:solidFill>
+                  <a:srgbClr val="6B4FA3"/>
                 </a:solidFill>
                 <a:latin typeface="Cambria" pitchFamily="34" charset="0"/>
                 <a:ea typeface="Cambria" pitchFamily="34" charset="-122"/>
@@ -22276,7 +22276,7 @@
               </a:rPr>
               <a:t>1</a:t>
             </a:r>
-            <a:endParaRPr lang="en-US" sz="2000" dirty="0"/>
+            <a:endParaRPr lang="en-US" sz="2200" dirty="0"/>
           </a:p>
         </p:txBody>
       </p:sp>
@@ -22288,8 +22288,8 @@
         </p:nvSpPr>
         <p:spPr>
           <a:xfrm>
-            <a:off x="1508760" y="1499616"/>
-            <a:ext cx="4297680" cy="731520"/>
+            <a:off x="1737360" y="1691640"/>
+            <a:ext cx="4023360" cy="731520"/>
           </a:xfrm>
           <a:prstGeom prst="rect">
             <a:avLst/>
@@ -22305,7 +22305,7 @@
               <a:buNone/>
             </a:pPr>
             <a:r>
-              <a:rPr lang="en-US" sz="1900" b="1" dirty="0">
+              <a:rPr lang="en-US" sz="2200" b="1" dirty="0">
                 <a:solidFill>
                   <a:srgbClr val="1F1A33"/>
                 </a:solidFill>
@@ -22315,7 +22315,7 @@
               </a:rPr>
               <a:t>Introduction</a:t>
             </a:r>
-            <a:endParaRPr lang="en-US" sz="1900" dirty="0"/>
+            <a:endParaRPr lang="en-US" sz="2200" dirty="0"/>
           </a:p>
         </p:txBody>
       </p:sp>
@@ -22327,12 +22327,12 @@
         </p:nvSpPr>
         <p:spPr>
           <a:xfrm>
-            <a:off x="548640" y="2395728"/>
-            <a:ext cx="5394960" cy="804672"/>
+            <a:off x="548640" y="2697480"/>
+            <a:ext cx="5394960" cy="914400"/>
           </a:xfrm>
           <a:prstGeom prst="roundRect">
             <a:avLst>
-              <a:gd name="adj" fmla="val 13636"/>
+              <a:gd name="adj" fmla="val 12000"/>
             </a:avLst>
           </a:prstGeom>
           <a:solidFill>
@@ -22348,24 +22348,24 @@
       </p:sp>
       <p:sp>
         <p:nvSpPr>
-          <p:cNvPr id="10" name="Number circle"/>
+          <p:cNvPr id="10" name="Gold diamond"/>
           <p:cNvSpPr/>
           <p:nvPr/>
         </p:nvSpPr>
         <p:spPr>
           <a:xfrm>
-            <a:off x="731520" y="2523744"/>
-            <a:ext cx="548640" cy="548640"/>
-          </a:xfrm>
-          <a:prstGeom prst="ellipse">
+            <a:off x="777240" y="2953512"/>
+            <a:ext cx="402336" cy="402336"/>
+          </a:xfrm>
+          <a:prstGeom prst="diamond">
             <a:avLst/>
           </a:prstGeom>
           <a:solidFill>
-            <a:srgbClr val="E0457B"/>
+            <a:srgbClr val="F2B134"/>
           </a:solidFill>
           <a:ln w="12700">
             <a:solidFill>
-              <a:srgbClr val="FFFFFF"/>
+              <a:srgbClr val="F2B134"/>
             </a:solidFill>
             <a:prstDash val="solid"/>
           </a:ln>
@@ -22379,8 +22379,8 @@
         </p:nvSpPr>
         <p:spPr>
           <a:xfrm>
-            <a:off x="731520" y="2523744"/>
-            <a:ext cx="548640" cy="548640"/>
+            <a:off x="1261872" y="2788920"/>
+            <a:ext cx="457200" cy="731520"/>
           </a:xfrm>
           <a:prstGeom prst="rect">
             <a:avLst/>
@@ -22392,13 +22392,13 @@
           <a:bodyPr wrap="square" lIns="0" tIns="0" rIns="0" bIns="0" rtlCol="0" anchor="ctr"/>
           <a:lstStyle/>
           <a:p>
-            <a:pPr algn="ctr" indent="0" marL="0">
+            <a:pPr indent="0" marL="0">
               <a:buNone/>
             </a:pPr>
             <a:r>
-              <a:rPr lang="en-US" sz="2000" b="1" dirty="0">
-                <a:solidFill>
-                  <a:srgbClr val="FFFFFF"/>
+              <a:rPr lang="en-US" sz="2200" b="1" dirty="0">
+                <a:solidFill>
+                  <a:srgbClr val="E0457B"/>
                 </a:solidFill>
                 <a:latin typeface="Cambria" pitchFamily="34" charset="0"/>
                 <a:ea typeface="Cambria" pitchFamily="34" charset="-122"/>
@@ -22406,7 +22406,7 @@
               </a:rPr>
               <a:t>2</a:t>
             </a:r>
-            <a:endParaRPr lang="en-US" sz="2000" dirty="0"/>
+            <a:endParaRPr lang="en-US" sz="2200" dirty="0"/>
           </a:p>
         </p:txBody>
       </p:sp>
@@ -22418,8 +22418,8 @@
         </p:nvSpPr>
         <p:spPr>
           <a:xfrm>
-            <a:off x="1508760" y="2432304"/>
-            <a:ext cx="4297680" cy="731520"/>
+            <a:off x="1737360" y="2788920"/>
+            <a:ext cx="4023360" cy="731520"/>
           </a:xfrm>
           <a:prstGeom prst="rect">
             <a:avLst/>
@@ -22435,7 +22435,7 @@
               <a:buNone/>
             </a:pPr>
             <a:r>
-              <a:rPr lang="en-US" sz="1900" b="1" dirty="0">
+              <a:rPr lang="en-US" sz="2200" b="1" dirty="0">
                 <a:solidFill>
                   <a:srgbClr val="1F1A33"/>
                 </a:solidFill>
@@ -22443,9 +22443,9 @@
                 <a:ea typeface="Calibri" pitchFamily="34" charset="-122"/>
                 <a:cs typeface="Calibri" pitchFamily="34" charset="-120"/>
               </a:rPr>
-              <a:t>Related work</a:t>
+              <a:t>Literature Review</a:t>
             </a:r>
-            <a:endParaRPr lang="en-US" sz="1900" dirty="0"/>
+            <a:endParaRPr lang="en-US" sz="2200" dirty="0"/>
           </a:p>
         </p:txBody>
       </p:sp>
@@ -22457,12 +22457,12 @@
         </p:nvSpPr>
         <p:spPr>
           <a:xfrm>
-            <a:off x="548640" y="3328416"/>
-            <a:ext cx="5394960" cy="804672"/>
+            <a:off x="548640" y="3794760"/>
+            <a:ext cx="5394960" cy="914400"/>
           </a:xfrm>
           <a:prstGeom prst="roundRect">
             <a:avLst>
-              <a:gd name="adj" fmla="val 13636"/>
+              <a:gd name="adj" fmla="val 12000"/>
             </a:avLst>
           </a:prstGeom>
           <a:solidFill>
@@ -22478,24 +22478,24 @@
       </p:sp>
       <p:sp>
         <p:nvSpPr>
-          <p:cNvPr id="14" name="Number circle"/>
+          <p:cNvPr id="14" name="Gold diamond"/>
           <p:cNvSpPr/>
           <p:nvPr/>
         </p:nvSpPr>
         <p:spPr>
           <a:xfrm>
-            <a:off x="731520" y="3456432"/>
-            <a:ext cx="548640" cy="548640"/>
-          </a:xfrm>
-          <a:prstGeom prst="ellipse">
+            <a:off x="777240" y="4050792"/>
+            <a:ext cx="402336" cy="402336"/>
+          </a:xfrm>
+          <a:prstGeom prst="diamond">
             <a:avLst/>
           </a:prstGeom>
           <a:solidFill>
-            <a:srgbClr val="6B4FA3"/>
+            <a:srgbClr val="F2B134"/>
           </a:solidFill>
           <a:ln w="12700">
             <a:solidFill>
-              <a:srgbClr val="FFFFFF"/>
+              <a:srgbClr val="F2B134"/>
             </a:solidFill>
             <a:prstDash val="solid"/>
           </a:ln>
@@ -22509,8 +22509,8 @@
         </p:nvSpPr>
         <p:spPr>
           <a:xfrm>
-            <a:off x="731520" y="3456432"/>
-            <a:ext cx="548640" cy="548640"/>
+            <a:off x="1261872" y="3886200"/>
+            <a:ext cx="457200" cy="731520"/>
           </a:xfrm>
           <a:prstGeom prst="rect">
             <a:avLst/>
@@ -22522,13 +22522,13 @@
           <a:bodyPr wrap="square" lIns="0" tIns="0" rIns="0" bIns="0" rtlCol="0" anchor="ctr"/>
           <a:lstStyle/>
           <a:p>
-            <a:pPr algn="ctr" indent="0" marL="0">
+            <a:pPr indent="0" marL="0">
               <a:buNone/>
             </a:pPr>
             <a:r>
-              <a:rPr lang="en-US" sz="2000" b="1" dirty="0">
-                <a:solidFill>
-                  <a:srgbClr val="FFFFFF"/>
+              <a:rPr lang="en-US" sz="2200" b="1" dirty="0">
+                <a:solidFill>
+                  <a:srgbClr val="6B4FA3"/>
                 </a:solidFill>
                 <a:latin typeface="Cambria" pitchFamily="34" charset="0"/>
                 <a:ea typeface="Cambria" pitchFamily="34" charset="-122"/>
@@ -22536,7 +22536,7 @@
               </a:rPr>
               <a:t>3</a:t>
             </a:r>
-            <a:endParaRPr lang="en-US" sz="2000" dirty="0"/>
+            <a:endParaRPr lang="en-US" sz="2200" dirty="0"/>
           </a:p>
         </p:txBody>
       </p:sp>
@@ -22548,8 +22548,8 @@
         </p:nvSpPr>
         <p:spPr>
           <a:xfrm>
-            <a:off x="1508760" y="3364992"/>
-            <a:ext cx="4297680" cy="731520"/>
+            <a:off x="1737360" y="3886200"/>
+            <a:ext cx="4023360" cy="731520"/>
           </a:xfrm>
           <a:prstGeom prst="rect">
             <a:avLst/>
@@ -22565,7 +22565,7 @@
               <a:buNone/>
             </a:pPr>
             <a:r>
-              <a:rPr lang="en-US" sz="1900" b="1" dirty="0">
+              <a:rPr lang="en-US" sz="2200" b="1" dirty="0">
                 <a:solidFill>
                   <a:srgbClr val="1F1A33"/>
                 </a:solidFill>
@@ -22573,9 +22573,9 @@
                 <a:ea typeface="Calibri" pitchFamily="34" charset="-122"/>
                 <a:cs typeface="Calibri" pitchFamily="34" charset="-120"/>
               </a:rPr>
-              <a:t>Research problems</a:t>
+              <a:t>Problem Statement</a:t>
             </a:r>
-            <a:endParaRPr lang="en-US" sz="1900" dirty="0"/>
+            <a:endParaRPr lang="en-US" sz="2200" dirty="0"/>
           </a:p>
         </p:txBody>
       </p:sp>
@@ -22587,12 +22587,12 @@
         </p:nvSpPr>
         <p:spPr>
           <a:xfrm>
-            <a:off x="548640" y="4261104"/>
-            <a:ext cx="5394960" cy="804672"/>
+            <a:off x="548640" y="4892040"/>
+            <a:ext cx="5394960" cy="914400"/>
           </a:xfrm>
           <a:prstGeom prst="roundRect">
             <a:avLst>
-              <a:gd name="adj" fmla="val 13636"/>
+              <a:gd name="adj" fmla="val 12000"/>
             </a:avLst>
           </a:prstGeom>
           <a:solidFill>
@@ -22608,24 +22608,24 @@
       </p:sp>
       <p:sp>
         <p:nvSpPr>
-          <p:cNvPr id="18" name="Number circle"/>
+          <p:cNvPr id="18" name="Gold diamond"/>
           <p:cNvSpPr/>
           <p:nvPr/>
         </p:nvSpPr>
         <p:spPr>
           <a:xfrm>
-            <a:off x="731520" y="4389120"/>
-            <a:ext cx="548640" cy="548640"/>
-          </a:xfrm>
-          <a:prstGeom prst="ellipse">
+            <a:off x="777240" y="5148072"/>
+            <a:ext cx="402336" cy="402336"/>
+          </a:xfrm>
+          <a:prstGeom prst="diamond">
             <a:avLst/>
           </a:prstGeom>
           <a:solidFill>
-            <a:srgbClr val="E0457B"/>
+            <a:srgbClr val="F2B134"/>
           </a:solidFill>
           <a:ln w="12700">
             <a:solidFill>
-              <a:srgbClr val="FFFFFF"/>
+              <a:srgbClr val="F2B134"/>
             </a:solidFill>
             <a:prstDash val="solid"/>
           </a:ln>
@@ -22639,8 +22639,8 @@
         </p:nvSpPr>
         <p:spPr>
           <a:xfrm>
-            <a:off x="731520" y="4389120"/>
-            <a:ext cx="548640" cy="548640"/>
+            <a:off x="1261872" y="4983480"/>
+            <a:ext cx="457200" cy="731520"/>
           </a:xfrm>
           <a:prstGeom prst="rect">
             <a:avLst/>
@@ -22652,13 +22652,13 @@
           <a:bodyPr wrap="square" lIns="0" tIns="0" rIns="0" bIns="0" rtlCol="0" anchor="ctr"/>
           <a:lstStyle/>
           <a:p>
-            <a:pPr algn="ctr" indent="0" marL="0">
+            <a:pPr indent="0" marL="0">
               <a:buNone/>
             </a:pPr>
             <a:r>
-              <a:rPr lang="en-US" sz="2000" b="1" dirty="0">
-                <a:solidFill>
-                  <a:srgbClr val="FFFFFF"/>
+              <a:rPr lang="en-US" sz="2200" b="1" dirty="0">
+                <a:solidFill>
+                  <a:srgbClr val="E0457B"/>
                 </a:solidFill>
                 <a:latin typeface="Cambria" pitchFamily="34" charset="0"/>
                 <a:ea typeface="Cambria" pitchFamily="34" charset="-122"/>
@@ -22666,7 +22666,7 @@
               </a:rPr>
               <a:t>4</a:t>
             </a:r>
-            <a:endParaRPr lang="en-US" sz="2000" dirty="0"/>
+            <a:endParaRPr lang="en-US" sz="2200" dirty="0"/>
           </a:p>
         </p:txBody>
       </p:sp>
@@ -22678,8 +22678,8 @@
         </p:nvSpPr>
         <p:spPr>
           <a:xfrm>
-            <a:off x="1508760" y="4297680"/>
-            <a:ext cx="4297680" cy="731520"/>
+            <a:off x="1737360" y="4983480"/>
+            <a:ext cx="4023360" cy="731520"/>
           </a:xfrm>
           <a:prstGeom prst="rect">
             <a:avLst/>
@@ -22695,7 +22695,7 @@
               <a:buNone/>
             </a:pPr>
             <a:r>
-              <a:rPr lang="en-US" sz="1900" b="1" dirty="0">
+              <a:rPr lang="en-US" sz="2200" b="1" dirty="0">
                 <a:solidFill>
                   <a:srgbClr val="1F1A33"/>
                 </a:solidFill>
@@ -22703,9 +22703,9 @@
                 <a:ea typeface="Calibri" pitchFamily="34" charset="-122"/>
                 <a:cs typeface="Calibri" pitchFamily="34" charset="-120"/>
               </a:rPr>
-              <a:t>Research objective</a:t>
+              <a:t>Thesis Objectives</a:t>
             </a:r>
-            <a:endParaRPr lang="en-US" sz="1900" dirty="0"/>
+            <a:endParaRPr lang="en-US" sz="2200" dirty="0"/>
           </a:p>
         </p:txBody>
       </p:sp>
@@ -22717,12 +22717,12 @@
         </p:nvSpPr>
         <p:spPr>
           <a:xfrm>
-            <a:off x="548640" y="5193792"/>
-            <a:ext cx="5394960" cy="804672"/>
+            <a:off x="6217920" y="1600200"/>
+            <a:ext cx="5394960" cy="914400"/>
           </a:xfrm>
           <a:prstGeom prst="roundRect">
             <a:avLst>
-              <a:gd name="adj" fmla="val 13636"/>
+              <a:gd name="adj" fmla="val 12000"/>
             </a:avLst>
           </a:prstGeom>
           <a:solidFill>
@@ -22738,24 +22738,24 @@
       </p:sp>
       <p:sp>
         <p:nvSpPr>
-          <p:cNvPr id="22" name="Number circle"/>
+          <p:cNvPr id="22" name="Gold diamond"/>
           <p:cNvSpPr/>
           <p:nvPr/>
         </p:nvSpPr>
         <p:spPr>
           <a:xfrm>
-            <a:off x="731520" y="5321808"/>
-            <a:ext cx="548640" cy="548640"/>
-          </a:xfrm>
-          <a:prstGeom prst="ellipse">
+            <a:off x="6446520" y="1856232"/>
+            <a:ext cx="402336" cy="402336"/>
+          </a:xfrm>
+          <a:prstGeom prst="diamond">
             <a:avLst/>
           </a:prstGeom>
           <a:solidFill>
-            <a:srgbClr val="6B4FA3"/>
+            <a:srgbClr val="F2B134"/>
           </a:solidFill>
           <a:ln w="12700">
             <a:solidFill>
-              <a:srgbClr val="FFFFFF"/>
+              <a:srgbClr val="F2B134"/>
             </a:solidFill>
             <a:prstDash val="solid"/>
           </a:ln>
@@ -22769,8 +22769,8 @@
         </p:nvSpPr>
         <p:spPr>
           <a:xfrm>
-            <a:off x="731520" y="5321808"/>
-            <a:ext cx="548640" cy="548640"/>
+            <a:off x="6931152" y="1691640"/>
+            <a:ext cx="457200" cy="731520"/>
           </a:xfrm>
           <a:prstGeom prst="rect">
             <a:avLst/>
@@ -22782,13 +22782,13 @@
           <a:bodyPr wrap="square" lIns="0" tIns="0" rIns="0" bIns="0" rtlCol="0" anchor="ctr"/>
           <a:lstStyle/>
           <a:p>
-            <a:pPr algn="ctr" indent="0" marL="0">
+            <a:pPr indent="0" marL="0">
               <a:buNone/>
             </a:pPr>
             <a:r>
-              <a:rPr lang="en-US" sz="2000" b="1" dirty="0">
-                <a:solidFill>
-                  <a:srgbClr val="FFFFFF"/>
+              <a:rPr lang="en-US" sz="2200" b="1" dirty="0">
+                <a:solidFill>
+                  <a:srgbClr val="6B4FA3"/>
                 </a:solidFill>
                 <a:latin typeface="Cambria" pitchFamily="34" charset="0"/>
                 <a:ea typeface="Cambria" pitchFamily="34" charset="-122"/>
@@ -22796,7 +22796,7 @@
               </a:rPr>
               <a:t>5</a:t>
             </a:r>
-            <a:endParaRPr lang="en-US" sz="2000" dirty="0"/>
+            <a:endParaRPr lang="en-US" sz="2200" dirty="0"/>
           </a:p>
         </p:txBody>
       </p:sp>
@@ -22808,8 +22808,8 @@
         </p:nvSpPr>
         <p:spPr>
           <a:xfrm>
-            <a:off x="1508760" y="5230368"/>
-            <a:ext cx="4297680" cy="731520"/>
+            <a:off x="7406640" y="1691640"/>
+            <a:ext cx="4023360" cy="731520"/>
           </a:xfrm>
           <a:prstGeom prst="rect">
             <a:avLst/>
@@ -22825,7 +22825,7 @@
               <a:buNone/>
             </a:pPr>
             <a:r>
-              <a:rPr lang="en-US" sz="1900" b="1" dirty="0">
+              <a:rPr lang="en-US" sz="2200" b="1" dirty="0">
                 <a:solidFill>
                   <a:srgbClr val="1F1A33"/>
                 </a:solidFill>
@@ -22833,9 +22833,9 @@
                 <a:ea typeface="Calibri" pitchFamily="34" charset="-122"/>
                 <a:cs typeface="Calibri" pitchFamily="34" charset="-120"/>
               </a:rPr>
-              <a:t>Proposed method</a:t>
+              <a:t>Proposed work</a:t>
             </a:r>
-            <a:endParaRPr lang="en-US" sz="1900" dirty="0"/>
+            <a:endParaRPr lang="en-US" sz="2200" dirty="0"/>
           </a:p>
         </p:txBody>
       </p:sp>
@@ -22847,12 +22847,12 @@
         </p:nvSpPr>
         <p:spPr>
           <a:xfrm>
-            <a:off x="6217920" y="1463040"/>
-            <a:ext cx="5394960" cy="804672"/>
+            <a:off x="6217920" y="2697480"/>
+            <a:ext cx="5394960" cy="914400"/>
           </a:xfrm>
           <a:prstGeom prst="roundRect">
             <a:avLst>
-              <a:gd name="adj" fmla="val 13636"/>
+              <a:gd name="adj" fmla="val 12000"/>
             </a:avLst>
           </a:prstGeom>
           <a:solidFill>
@@ -22868,24 +22868,24 @@
       </p:sp>
       <p:sp>
         <p:nvSpPr>
-          <p:cNvPr id="26" name="Number circle"/>
+          <p:cNvPr id="26" name="Gold diamond"/>
           <p:cNvSpPr/>
           <p:nvPr/>
         </p:nvSpPr>
         <p:spPr>
           <a:xfrm>
-            <a:off x="6400800" y="1591056"/>
-            <a:ext cx="548640" cy="548640"/>
-          </a:xfrm>
-          <a:prstGeom prst="ellipse">
+            <a:off x="6446520" y="2953512"/>
+            <a:ext cx="402336" cy="402336"/>
+          </a:xfrm>
+          <a:prstGeom prst="diamond">
             <a:avLst/>
           </a:prstGeom>
           <a:solidFill>
-            <a:srgbClr val="E0457B"/>
+            <a:srgbClr val="F2B134"/>
           </a:solidFill>
           <a:ln w="12700">
             <a:solidFill>
-              <a:srgbClr val="FFFFFF"/>
+              <a:srgbClr val="F2B134"/>
             </a:solidFill>
             <a:prstDash val="solid"/>
           </a:ln>
@@ -22899,8 +22899,8 @@
         </p:nvSpPr>
         <p:spPr>
           <a:xfrm>
-            <a:off x="6400800" y="1591056"/>
-            <a:ext cx="548640" cy="548640"/>
+            <a:off x="6931152" y="2788920"/>
+            <a:ext cx="457200" cy="731520"/>
           </a:xfrm>
           <a:prstGeom prst="rect">
             <a:avLst/>
@@ -22912,13 +22912,13 @@
           <a:bodyPr wrap="square" lIns="0" tIns="0" rIns="0" bIns="0" rtlCol="0" anchor="ctr"/>
           <a:lstStyle/>
           <a:p>
-            <a:pPr algn="ctr" indent="0" marL="0">
+            <a:pPr indent="0" marL="0">
               <a:buNone/>
             </a:pPr>
             <a:r>
-              <a:rPr lang="en-US" sz="2000" b="1" dirty="0">
-                <a:solidFill>
-                  <a:srgbClr val="FFFFFF"/>
+              <a:rPr lang="en-US" sz="2200" b="1" dirty="0">
+                <a:solidFill>
+                  <a:srgbClr val="E0457B"/>
                 </a:solidFill>
                 <a:latin typeface="Cambria" pitchFamily="34" charset="0"/>
                 <a:ea typeface="Cambria" pitchFamily="34" charset="-122"/>
@@ -22926,7 +22926,7 @@
               </a:rPr>
               <a:t>6</a:t>
             </a:r>
-            <a:endParaRPr lang="en-US" sz="2000" dirty="0"/>
+            <a:endParaRPr lang="en-US" sz="2200" dirty="0"/>
           </a:p>
         </p:txBody>
       </p:sp>
@@ -22938,8 +22938,8 @@
         </p:nvSpPr>
         <p:spPr>
           <a:xfrm>
-            <a:off x="7178040" y="1499616"/>
-            <a:ext cx="4297680" cy="731520"/>
+            <a:off x="7406640" y="2788920"/>
+            <a:ext cx="4023360" cy="731520"/>
           </a:xfrm>
           <a:prstGeom prst="rect">
             <a:avLst/>
@@ -22955,7 +22955,7 @@
               <a:buNone/>
             </a:pPr>
             <a:r>
-              <a:rPr lang="en-US" sz="1900" b="1" dirty="0">
+              <a:rPr lang="en-US" sz="2200" b="1" dirty="0">
                 <a:solidFill>
                   <a:srgbClr val="1F1A33"/>
                 </a:solidFill>
@@ -22963,9 +22963,9 @@
                 <a:ea typeface="Calibri" pitchFamily="34" charset="-122"/>
                 <a:cs typeface="Calibri" pitchFamily="34" charset="-120"/>
               </a:rPr>
-              <a:t>Proposed parallel computing strategies</a:t>
+              <a:t>Experimental Results</a:t>
             </a:r>
-            <a:endParaRPr lang="en-US" sz="1900" dirty="0"/>
+            <a:endParaRPr lang="en-US" sz="2200" dirty="0"/>
           </a:p>
         </p:txBody>
       </p:sp>
@@ -22977,12 +22977,12 @@
         </p:nvSpPr>
         <p:spPr>
           <a:xfrm>
-            <a:off x="6217920" y="2395728"/>
-            <a:ext cx="5394960" cy="804672"/>
+            <a:off x="6217920" y="3794760"/>
+            <a:ext cx="5394960" cy="914400"/>
           </a:xfrm>
           <a:prstGeom prst="roundRect">
             <a:avLst>
-              <a:gd name="adj" fmla="val 13636"/>
+              <a:gd name="adj" fmla="val 12000"/>
             </a:avLst>
           </a:prstGeom>
           <a:solidFill>
@@ -22998,24 +22998,24 @@
       </p:sp>
       <p:sp>
         <p:nvSpPr>
-          <p:cNvPr id="30" name="Number circle"/>
+          <p:cNvPr id="30" name="Gold diamond"/>
           <p:cNvSpPr/>
           <p:nvPr/>
         </p:nvSpPr>
         <p:spPr>
           <a:xfrm>
-            <a:off x="6400800" y="2523744"/>
-            <a:ext cx="548640" cy="548640"/>
-          </a:xfrm>
-          <a:prstGeom prst="ellipse">
+            <a:off x="6446520" y="4050792"/>
+            <a:ext cx="402336" cy="402336"/>
+          </a:xfrm>
+          <a:prstGeom prst="diamond">
             <a:avLst/>
           </a:prstGeom>
           <a:solidFill>
-            <a:srgbClr val="6B4FA3"/>
+            <a:srgbClr val="F2B134"/>
           </a:solidFill>
           <a:ln w="12700">
             <a:solidFill>
-              <a:srgbClr val="FFFFFF"/>
+              <a:srgbClr val="F2B134"/>
             </a:solidFill>
             <a:prstDash val="solid"/>
           </a:ln>
@@ -23029,8 +23029,8 @@
         </p:nvSpPr>
         <p:spPr>
           <a:xfrm>
-            <a:off x="6400800" y="2523744"/>
-            <a:ext cx="548640" cy="548640"/>
+            <a:off x="6931152" y="3886200"/>
+            <a:ext cx="457200" cy="731520"/>
           </a:xfrm>
           <a:prstGeom prst="rect">
             <a:avLst/>
@@ -23042,13 +23042,13 @@
           <a:bodyPr wrap="square" lIns="0" tIns="0" rIns="0" bIns="0" rtlCol="0" anchor="ctr"/>
           <a:lstStyle/>
           <a:p>
-            <a:pPr algn="ctr" indent="0" marL="0">
+            <a:pPr indent="0" marL="0">
               <a:buNone/>
             </a:pPr>
             <a:r>
-              <a:rPr lang="en-US" sz="2000" b="1" dirty="0">
-                <a:solidFill>
-                  <a:srgbClr val="FFFFFF"/>
+              <a:rPr lang="en-US" sz="2200" b="1" dirty="0">
+                <a:solidFill>
+                  <a:srgbClr val="6B4FA3"/>
                 </a:solidFill>
                 <a:latin typeface="Cambria" pitchFamily="34" charset="0"/>
                 <a:ea typeface="Cambria" pitchFamily="34" charset="-122"/>
@@ -23056,7 +23056,7 @@
               </a:rPr>
               <a:t>7</a:t>
             </a:r>
-            <a:endParaRPr lang="en-US" sz="2000" dirty="0"/>
+            <a:endParaRPr lang="en-US" sz="2200" dirty="0"/>
           </a:p>
         </p:txBody>
       </p:sp>
@@ -23068,8 +23068,8 @@
         </p:nvSpPr>
         <p:spPr>
           <a:xfrm>
-            <a:off x="7178040" y="2432304"/>
-            <a:ext cx="4297680" cy="731520"/>
+            <a:off x="7406640" y="3886200"/>
+            <a:ext cx="4023360" cy="731520"/>
           </a:xfrm>
           <a:prstGeom prst="rect">
             <a:avLst/>
@@ -23085,7 +23085,7 @@
               <a:buNone/>
             </a:pPr>
             <a:r>
-              <a:rPr lang="en-US" sz="1900" b="1" dirty="0">
+              <a:rPr lang="en-US" sz="2200" b="1" dirty="0">
                 <a:solidFill>
                   <a:srgbClr val="1F1A33"/>
                 </a:solidFill>
@@ -23093,9 +23093,9 @@
                 <a:ea typeface="Calibri" pitchFamily="34" charset="-122"/>
                 <a:cs typeface="Calibri" pitchFamily="34" charset="-120"/>
               </a:rPr>
-              <a:t>Results and discussion</a:t>
+              <a:t>Conclusion</a:t>
             </a:r>
-            <a:endParaRPr lang="en-US" sz="1900" dirty="0"/>
+            <a:endParaRPr lang="en-US" sz="2200" dirty="0"/>
           </a:p>
         </p:txBody>
       </p:sp>
@@ -23107,12 +23107,12 @@
         </p:nvSpPr>
         <p:spPr>
           <a:xfrm>
-            <a:off x="6217920" y="3328416"/>
-            <a:ext cx="5394960" cy="804672"/>
+            <a:off x="6217920" y="4892040"/>
+            <a:ext cx="5394960" cy="914400"/>
           </a:xfrm>
           <a:prstGeom prst="roundRect">
             <a:avLst>
-              <a:gd name="adj" fmla="val 13636"/>
+              <a:gd name="adj" fmla="val 12000"/>
             </a:avLst>
           </a:prstGeom>
           <a:solidFill>
@@ -23128,24 +23128,24 @@
       </p:sp>
       <p:sp>
         <p:nvSpPr>
-          <p:cNvPr id="34" name="Number circle"/>
+          <p:cNvPr id="34" name="Gold diamond"/>
           <p:cNvSpPr/>
           <p:nvPr/>
         </p:nvSpPr>
         <p:spPr>
           <a:xfrm>
-            <a:off x="6400800" y="3456432"/>
-            <a:ext cx="548640" cy="548640"/>
-          </a:xfrm>
-          <a:prstGeom prst="ellipse">
+            <a:off x="6446520" y="5148072"/>
+            <a:ext cx="402336" cy="402336"/>
+          </a:xfrm>
+          <a:prstGeom prst="diamond">
             <a:avLst/>
           </a:prstGeom>
           <a:solidFill>
-            <a:srgbClr val="E0457B"/>
+            <a:srgbClr val="F2B134"/>
           </a:solidFill>
           <a:ln w="12700">
             <a:solidFill>
-              <a:srgbClr val="FFFFFF"/>
+              <a:srgbClr val="F2B134"/>
             </a:solidFill>
             <a:prstDash val="solid"/>
           </a:ln>
@@ -23159,8 +23159,8 @@
         </p:nvSpPr>
         <p:spPr>
           <a:xfrm>
-            <a:off x="6400800" y="3456432"/>
-            <a:ext cx="548640" cy="548640"/>
+            <a:off x="6931152" y="4983480"/>
+            <a:ext cx="457200" cy="731520"/>
           </a:xfrm>
           <a:prstGeom prst="rect">
             <a:avLst/>
@@ -23172,13 +23172,13 @@
           <a:bodyPr wrap="square" lIns="0" tIns="0" rIns="0" bIns="0" rtlCol="0" anchor="ctr"/>
           <a:lstStyle/>
           <a:p>
-            <a:pPr algn="ctr" indent="0" marL="0">
+            <a:pPr indent="0" marL="0">
               <a:buNone/>
             </a:pPr>
             <a:r>
-              <a:rPr lang="en-US" sz="2000" b="1" dirty="0">
-                <a:solidFill>
-                  <a:srgbClr val="FFFFFF"/>
+              <a:rPr lang="en-US" sz="2200" b="1" dirty="0">
+                <a:solidFill>
+                  <a:srgbClr val="E0457B"/>
                 </a:solidFill>
                 <a:latin typeface="Cambria" pitchFamily="34" charset="0"/>
                 <a:ea typeface="Cambria" pitchFamily="34" charset="-122"/>
@@ -23186,7 +23186,7 @@
               </a:rPr>
               <a:t>8</a:t>
             </a:r>
-            <a:endParaRPr lang="en-US" sz="2000" dirty="0"/>
+            <a:endParaRPr lang="en-US" sz="2200" dirty="0"/>
           </a:p>
         </p:txBody>
       </p:sp>
@@ -23198,8 +23198,8 @@
         </p:nvSpPr>
         <p:spPr>
           <a:xfrm>
-            <a:off x="7178040" y="3364992"/>
-            <a:ext cx="4297680" cy="731520"/>
+            <a:off x="7406640" y="4983480"/>
+            <a:ext cx="4023360" cy="731520"/>
           </a:xfrm>
           <a:prstGeom prst="rect">
             <a:avLst/>
@@ -23215,7 +23215,7 @@
               <a:buNone/>
             </a:pPr>
             <a:r>
-              <a:rPr lang="en-US" sz="1900" b="1" dirty="0">
+              <a:rPr lang="en-US" sz="2200" b="1" dirty="0">
                 <a:solidFill>
                   <a:srgbClr val="1F1A33"/>
                 </a:solidFill>
@@ -23223,139 +23223,9 @@
                 <a:ea typeface="Calibri" pitchFamily="34" charset="-122"/>
                 <a:cs typeface="Calibri" pitchFamily="34" charset="-120"/>
               </a:rPr>
-              <a:t>Conclusion</a:t>
+              <a:t>Future work</a:t>
             </a:r>
-            <a:endParaRPr lang="en-US" sz="1900" dirty="0"/>
-          </a:p>
-        </p:txBody>
-      </p:sp>
-      <p:sp>
-        <p:nvSpPr>
-          <p:cNvPr id="37" name="Agenda card"/>
-          <p:cNvSpPr/>
-          <p:nvPr/>
-        </p:nvSpPr>
-        <p:spPr>
-          <a:xfrm>
-            <a:off x="6217920" y="4261104"/>
-            <a:ext cx="5394960" cy="804672"/>
-          </a:xfrm>
-          <a:prstGeom prst="roundRect">
-            <a:avLst>
-              <a:gd name="adj" fmla="val 13636"/>
-            </a:avLst>
-          </a:prstGeom>
-          <a:solidFill>
-            <a:srgbClr val="F5F1FB"/>
-          </a:solidFill>
-          <a:ln w="12700">
-            <a:solidFill>
-              <a:srgbClr val="F5F1FB"/>
-            </a:solidFill>
-            <a:prstDash val="solid"/>
-          </a:ln>
-        </p:spPr>
-      </p:sp>
-      <p:sp>
-        <p:nvSpPr>
-          <p:cNvPr id="38" name="Number circle"/>
-          <p:cNvSpPr/>
-          <p:nvPr/>
-        </p:nvSpPr>
-        <p:spPr>
-          <a:xfrm>
-            <a:off x="6400800" y="4389120"/>
-            <a:ext cx="548640" cy="548640"/>
-          </a:xfrm>
-          <a:prstGeom prst="ellipse">
-            <a:avLst/>
-          </a:prstGeom>
-          <a:solidFill>
-            <a:srgbClr val="6B4FA3"/>
-          </a:solidFill>
-          <a:ln w="12700">
-            <a:solidFill>
-              <a:srgbClr val="FFFFFF"/>
-            </a:solidFill>
-            <a:prstDash val="solid"/>
-          </a:ln>
-        </p:spPr>
-      </p:sp>
-      <p:sp>
-        <p:nvSpPr>
-          <p:cNvPr id="39" name="Text 36"/>
-          <p:cNvSpPr txBox="1"/>
-          <p:nvPr/>
-        </p:nvSpPr>
-        <p:spPr>
-          <a:xfrm>
-            <a:off x="6400800" y="4389120"/>
-            <a:ext cx="548640" cy="548640"/>
-          </a:xfrm>
-          <a:prstGeom prst="rect">
-            <a:avLst/>
-          </a:prstGeom>
-          <a:noFill/>
-          <a:ln/>
-        </p:spPr>
-        <p:txBody>
-          <a:bodyPr wrap="square" lIns="0" tIns="0" rIns="0" bIns="0" rtlCol="0" anchor="ctr"/>
-          <a:lstStyle/>
-          <a:p>
-            <a:pPr algn="ctr" indent="0" marL="0">
-              <a:buNone/>
-            </a:pPr>
-            <a:r>
-              <a:rPr lang="en-US" sz="2000" b="1" dirty="0">
-                <a:solidFill>
-                  <a:srgbClr val="FFFFFF"/>
-                </a:solidFill>
-                <a:latin typeface="Cambria" pitchFamily="34" charset="0"/>
-                <a:ea typeface="Cambria" pitchFamily="34" charset="-122"/>
-                <a:cs typeface="Cambria" pitchFamily="34" charset="-120"/>
-              </a:rPr>
-              <a:t>9</a:t>
-            </a:r>
-            <a:endParaRPr lang="en-US" sz="2000" dirty="0"/>
-          </a:p>
-        </p:txBody>
-      </p:sp>
-      <p:sp>
-        <p:nvSpPr>
-          <p:cNvPr id="40" name="Text 37"/>
-          <p:cNvSpPr txBox="1"/>
-          <p:nvPr/>
-        </p:nvSpPr>
-        <p:spPr>
-          <a:xfrm>
-            <a:off x="7178040" y="4297680"/>
-            <a:ext cx="4297680" cy="731520"/>
-          </a:xfrm>
-          <a:prstGeom prst="rect">
-            <a:avLst/>
-          </a:prstGeom>
-          <a:noFill/>
-          <a:ln/>
-        </p:spPr>
-        <p:txBody>
-          <a:bodyPr wrap="square" lIns="0" tIns="0" rIns="0" bIns="0" rtlCol="0" anchor="ctr"/>
-          <a:lstStyle/>
-          <a:p>
-            <a:pPr indent="0" marL="0">
-              <a:buNone/>
-            </a:pPr>
-            <a:r>
-              <a:rPr lang="en-US" sz="1900" b="1" dirty="0">
-                <a:solidFill>
-                  <a:srgbClr val="1F1A33"/>
-                </a:solidFill>
-                <a:latin typeface="Calibri" pitchFamily="34" charset="0"/>
-                <a:ea typeface="Calibri" pitchFamily="34" charset="-122"/>
-                <a:cs typeface="Calibri" pitchFamily="34" charset="-120"/>
-              </a:rPr>
-              <a:t>References</a:t>
-            </a:r>
-            <a:endParaRPr lang="en-US" sz="1900" dirty="0"/>
+            <a:endParaRPr lang="en-US" sz="2200" dirty="0"/>
           </a:p>
         </p:txBody>
       </p:sp>
@@ -23465,7 +23335,7 @@
                 <a:ea typeface="Calibri" pitchFamily="34" charset="-122"/>
                 <a:cs typeface="Calibri" pitchFamily="34" charset="-120"/>
               </a:rPr>
-              <a:t>6 · PROPOSED PARALLEL COMPUTING STRATEGIES</a:t>
+              <a:t>5 · PROPOSED WORK</a:t>
             </a:r>
             <a:endParaRPr lang="en-US" sz="1100" dirty="0"/>
           </a:p>
@@ -24873,7 +24743,7 @@
                 <a:ea typeface="Calibri" pitchFamily="34" charset="-122"/>
                 <a:cs typeface="Calibri" pitchFamily="34" charset="-120"/>
               </a:rPr>
-              <a:t>7 · RESULTS AND DISCUSSION</a:t>
+              <a:t>6 · EXPERIMENTAL RESULTS</a:t>
             </a:r>
             <a:endParaRPr lang="en-US" sz="1100" dirty="0"/>
           </a:p>
@@ -25124,7 +24994,7 @@
                 <a:ea typeface="Calibri" pitchFamily="34" charset="-122"/>
                 <a:cs typeface="Calibri" pitchFamily="34" charset="-120"/>
               </a:rPr>
-              <a:t>7 · RESULTS AND DISCUSSION</a:t>
+              <a:t>6 · EXPERIMENTAL RESULTS</a:t>
             </a:r>
             <a:endParaRPr lang="en-US" sz="1100" dirty="0"/>
           </a:p>
@@ -25640,7 +25510,7 @@
                 <a:ea typeface="Calibri" pitchFamily="34" charset="-122"/>
                 <a:cs typeface="Calibri" pitchFamily="34" charset="-120"/>
               </a:rPr>
-              <a:t>7 · RESULTS AND DISCUSSION</a:t>
+              <a:t>6 · EXPERIMENTAL RESULTS</a:t>
             </a:r>
             <a:endParaRPr lang="en-US" sz="1100" dirty="0"/>
           </a:p>
@@ -26156,7 +26026,7 @@
                 <a:ea typeface="Calibri" pitchFamily="34" charset="-122"/>
                 <a:cs typeface="Calibri" pitchFamily="34" charset="-120"/>
               </a:rPr>
-              <a:t>7 · RESULTS AND DISCUSSION</a:t>
+              <a:t>6 · EXPERIMENTAL RESULTS</a:t>
             </a:r>
             <a:endParaRPr lang="en-US" sz="1100" dirty="0"/>
           </a:p>
@@ -26915,7 +26785,7 @@
                 <a:ea typeface="Calibri" pitchFamily="34" charset="-122"/>
                 <a:cs typeface="Calibri" pitchFamily="34" charset="-120"/>
               </a:rPr>
-              <a:t>7 · RESULTS AND DISCUSSION</a:t>
+              <a:t>6 · EXPERIMENTAL RESULTS</a:t>
             </a:r>
             <a:endParaRPr lang="en-US" sz="1100" dirty="0"/>
           </a:p>
@@ -27216,7 +27086,7 @@
                 <a:ea typeface="Calibri" pitchFamily="34" charset="-122"/>
                 <a:cs typeface="Calibri" pitchFamily="34" charset="-120"/>
               </a:rPr>
-              <a:t>7 · RESULTS AND DISCUSSION</a:t>
+              <a:t>6 · EXPERIMENTAL RESULTS</a:t>
             </a:r>
             <a:endParaRPr lang="en-US" sz="1100" dirty="0"/>
           </a:p>
@@ -27677,7 +27547,7 @@
                 <a:ea typeface="Calibri" pitchFamily="34" charset="-122"/>
                 <a:cs typeface="Calibri" pitchFamily="34" charset="-120"/>
               </a:rPr>
-              <a:t>7 · RESULTS AND DISCUSSION</a:t>
+              <a:t>6 · EXPERIMENTAL RESULTS</a:t>
             </a:r>
             <a:endParaRPr lang="en-US" sz="1100" dirty="0"/>
           </a:p>
@@ -28122,7 +27992,7 @@
                 <a:ea typeface="Calibri" pitchFamily="34" charset="-122"/>
                 <a:cs typeface="Calibri" pitchFamily="34" charset="-120"/>
               </a:rPr>
-              <a:t>7 · RESULTS AND DISCUSSION</a:t>
+              <a:t>6 · EXPERIMENTAL RESULTS</a:t>
             </a:r>
             <a:endParaRPr lang="en-US" sz="1100" dirty="0"/>
           </a:p>
@@ -28373,7 +28243,7 @@
                 <a:ea typeface="Calibri" pitchFamily="34" charset="-122"/>
                 <a:cs typeface="Calibri" pitchFamily="34" charset="-120"/>
               </a:rPr>
-              <a:t>7 · RESULTS AND DISCUSSION</a:t>
+              <a:t>6 · EXPERIMENTAL RESULTS</a:t>
             </a:r>
             <a:endParaRPr lang="en-US" sz="1100" dirty="0"/>
           </a:p>
@@ -29670,7 +29540,7 @@
                 <a:ea typeface="Calibri" pitchFamily="34" charset="-122"/>
                 <a:cs typeface="Calibri" pitchFamily="34" charset="-120"/>
               </a:rPr>
-              <a:t>7 · RESULTS AND DISCUSSION</a:t>
+              <a:t>6 · EXPERIMENTAL RESULTS</a:t>
             </a:r>
             <a:endParaRPr lang="en-US" sz="1100" dirty="0"/>
           </a:p>
@@ -30115,7 +29985,7 @@
                 <a:ea typeface="Calibri" pitchFamily="34" charset="-122"/>
                 <a:cs typeface="Calibri" pitchFamily="34" charset="-120"/>
               </a:rPr>
-              <a:t>7 · RESULTS AND DISCUSSION</a:t>
+              <a:t>6 · EXPERIMENTAL RESULTS</a:t>
             </a:r>
             <a:endParaRPr lang="en-US" sz="1100" dirty="0"/>
           </a:p>
@@ -30366,7 +30236,7 @@
                 <a:ea typeface="Calibri" pitchFamily="34" charset="-122"/>
                 <a:cs typeface="Calibri" pitchFamily="34" charset="-120"/>
               </a:rPr>
-              <a:t>7 · RESULTS AND DISCUSSION</a:t>
+              <a:t>6 · EXPERIMENTAL RESULTS</a:t>
             </a:r>
             <a:endParaRPr lang="en-US" sz="1100" dirty="0"/>
           </a:p>
@@ -30617,7 +30487,7 @@
                 <a:ea typeface="Calibri" pitchFamily="34" charset="-122"/>
                 <a:cs typeface="Calibri" pitchFamily="34" charset="-120"/>
               </a:rPr>
-              <a:t>7 · RESULTS AND DISCUSSION</a:t>
+              <a:t>6 · EXPERIMENTAL RESULTS</a:t>
             </a:r>
             <a:endParaRPr lang="en-US" sz="1100" dirty="0"/>
           </a:p>
@@ -31062,7 +30932,7 @@
                 <a:ea typeface="Calibri" pitchFamily="34" charset="-122"/>
                 <a:cs typeface="Calibri" pitchFamily="34" charset="-120"/>
               </a:rPr>
-              <a:t>7 · RESULTS AND DISCUSSION</a:t>
+              <a:t>6 · EXPERIMENTAL RESULTS</a:t>
             </a:r>
             <a:endParaRPr lang="en-US" sz="1100" dirty="0"/>
           </a:p>
@@ -33777,7 +33647,7 @@
                 <a:ea typeface="Calibri" pitchFamily="34" charset="-122"/>
                 <a:cs typeface="Calibri" pitchFamily="34" charset="-120"/>
               </a:rPr>
-              <a:t>7 · RESULTS AND DISCUSSION</a:t>
+              <a:t>6 · EXPERIMENTAL RESULTS</a:t>
             </a:r>
             <a:endParaRPr lang="en-US" sz="1100" dirty="0"/>
           </a:p>
@@ -35603,7 +35473,7 @@
                 <a:ea typeface="Calibri" pitchFamily="34" charset="-122"/>
                 <a:cs typeface="Calibri" pitchFamily="34" charset="-120"/>
               </a:rPr>
-              <a:t>8 · CONCLUSION</a:t>
+              <a:t>7 · CONCLUSION</a:t>
             </a:r>
             <a:endParaRPr lang="en-US" sz="1100" dirty="0"/>
           </a:p>
@@ -36372,7 +36242,7 @@
                 <a:ea typeface="Calibri" pitchFamily="34" charset="-122"/>
                 <a:cs typeface="Calibri" pitchFamily="34" charset="-120"/>
               </a:rPr>
-              <a:t>8 · CONCLUSION</a:t>
+              <a:t>7 · CONCLUSION</a:t>
             </a:r>
             <a:endParaRPr lang="en-US" sz="1100" dirty="0"/>
           </a:p>
@@ -37078,7 +36948,7 @@
                 <a:ea typeface="Calibri" pitchFamily="34" charset="-122"/>
                 <a:cs typeface="Calibri" pitchFamily="34" charset="-120"/>
               </a:rPr>
-              <a:t>8 · CONCLUSION</a:t>
+              <a:t>8 · FUTURE WORK</a:t>
             </a:r>
             <a:endParaRPr lang="en-US" sz="1100" dirty="0"/>
           </a:p>
@@ -37847,7 +37717,7 @@
                 <a:ea typeface="Calibri" pitchFamily="34" charset="-122"/>
                 <a:cs typeface="Calibri" pitchFamily="34" charset="-120"/>
               </a:rPr>
-              <a:t>9 · REFERENCES</a:t>
+              <a:t>REFERENCES</a:t>
             </a:r>
             <a:endParaRPr lang="en-US" sz="1100" dirty="0"/>
           </a:p>
@@ -40274,7 +40144,7 @@
                 <a:ea typeface="Calibri" pitchFamily="34" charset="-122"/>
                 <a:cs typeface="Calibri" pitchFamily="34" charset="-120"/>
               </a:rPr>
-              <a:t>2 · RELATED WORK</a:t>
+              <a:t>2 · LITERATURE REVIEW</a:t>
             </a:r>
             <a:endParaRPr lang="en-US" sz="1100" dirty="0"/>
           </a:p>
@@ -40315,7 +40185,7 @@
                 <a:ea typeface="Cambria" pitchFamily="34" charset="-122"/>
                 <a:cs typeface="Cambria" pitchFamily="34" charset="-120"/>
               </a:rPr>
-              <a:t>Related work: image-compression studies</a:t>
+              <a:t>Literature review: image-compression studies</a:t>
             </a:r>
             <a:endParaRPr lang="en-US" sz="3000" dirty="0"/>
           </a:p>
@@ -41895,7 +41765,7 @@
                 <a:ea typeface="Calibri" pitchFamily="34" charset="-122"/>
                 <a:cs typeface="Calibri" pitchFamily="34" charset="-120"/>
               </a:rPr>
-              <a:t>2 · RELATED WORK</a:t>
+              <a:t>2 · LITERATURE REVIEW</a:t>
             </a:r>
             <a:endParaRPr lang="en-US" sz="1100" dirty="0"/>
           </a:p>
@@ -41936,7 +41806,7 @@
                 <a:ea typeface="Cambria" pitchFamily="34" charset="-122"/>
                 <a:cs typeface="Cambria" pitchFamily="34" charset="-120"/>
               </a:rPr>
-              <a:t>Related work: parallel studies</a:t>
+              <a:t>Literature review: parallel studies</a:t>
             </a:r>
             <a:endParaRPr lang="en-US" sz="3000" dirty="0"/>
           </a:p>
@@ -43516,7 +43386,7 @@
                 <a:ea typeface="Calibri" pitchFamily="34" charset="-122"/>
                 <a:cs typeface="Calibri" pitchFamily="34" charset="-120"/>
               </a:rPr>
-              <a:t>3 · RESEARCH PROBLEMS</a:t>
+              <a:t>3 · PROBLEM STATEMENT</a:t>
             </a:r>
             <a:endParaRPr lang="en-US" sz="1100" dirty="0"/>
           </a:p>
@@ -43557,7 +43427,7 @@
                 <a:ea typeface="Cambria" pitchFamily="34" charset="-122"/>
                 <a:cs typeface="Cambria" pitchFamily="34" charset="-120"/>
               </a:rPr>
-              <a:t>Research problems</a:t>
+              <a:t>Problem Statement</a:t>
             </a:r>
             <a:endParaRPr lang="en-US" sz="3000" dirty="0"/>
           </a:p>
@@ -44285,7 +44155,7 @@
                 <a:ea typeface="Calibri" pitchFamily="34" charset="-122"/>
                 <a:cs typeface="Calibri" pitchFamily="34" charset="-120"/>
               </a:rPr>
-              <a:t>4 · RESEARCH OBJECTIVE</a:t>
+              <a:t>4 · THESIS OBJECTIVES</a:t>
             </a:r>
             <a:endParaRPr lang="en-US" sz="1100" dirty="0"/>
           </a:p>
@@ -44326,7 +44196,7 @@
                 <a:ea typeface="Cambria" pitchFamily="34" charset="-122"/>
                 <a:cs typeface="Cambria" pitchFamily="34" charset="-120"/>
               </a:rPr>
-              <a:t>Research objective</a:t>
+              <a:t>Thesis Objectives</a:t>
             </a:r>
             <a:endParaRPr lang="en-US" sz="3000" dirty="0"/>
           </a:p>

</xml_diff>